<commit_message>
docs(tibi): align exact CSV and tool module names across README, test matrix and presentation
</commit_message>
<xml_diff>
--- a/Presentacion_TFG_TIBI_Orange.pptx
+++ b/Presentacion_TFG_TIBI_Orange.pptx
@@ -4587,7 +4587,7 @@
                 </a:solidFill>
                 <a:latin typeface="Arial"/>
               </a:rPr>
-              <a:t>tools/tools.py</a:t>
+              <a:t>tools/*.py</a:t>
             </a:r>
           </a:p>
         </p:txBody>
@@ -4622,7 +4622,7 @@
                 </a:solidFill>
                 <a:latin typeface="Arial"/>
               </a:rPr>
-              <a:t>Funciones Python deterministas (acceso a datos)</a:t>
+              <a:t>csv_tools.py y excalibur_tools.py (acceso a datos)</a:t>
             </a:r>
           </a:p>
         </p:txBody>
@@ -4737,7 +4737,7 @@
                 </a:solidFill>
                 <a:latin typeface="Arial"/>
               </a:rPr>
-              <a:t>BBDD local simulada (10.000 clientes y SVA)</a:t>
+              <a:t>cliente_credencial 1.csv y usuarios_servicios.csv</a:t>
             </a:r>
           </a:p>
         </p:txBody>
@@ -4967,7 +4967,7 @@
                 </a:solidFill>
                 <a:latin typeface="Arial"/>
               </a:rPr>
-              <a:t>Registro técnico de servidor y herramientas</a:t>
+              <a:t>Registro técnico por agente, servidor y tools</a:t>
             </a:r>
           </a:p>
         </p:txBody>
@@ -7294,7 +7294,7 @@
                 </a:solidFill>
                 <a:latin typeface="Arial"/>
               </a:rPr>
-              <a:t>tools/tools.py</a:t>
+              <a:t>tools/*.py</a:t>
             </a:r>
           </a:p>
         </p:txBody>
@@ -7785,7 +7785,7 @@
                 </a:solidFill>
                 <a:latin typeface="Arial"/>
               </a:rPr>
-              <a:t>Prevención total de alucinaciones en datos críticos: el modelo de lenguaje nunca inventa contraseñas ni asume qué paquetes tiene un cliente; está obligado a consultar tools.py.</a:t>
+              <a:t>Prevención total de alucinaciones en datos críticos: el modelo de lenguaje nunca inventa contraseñas ni asume qué paquetes tiene un cliente; está obligado a consultar csv_tools.py.</a:t>
             </a:r>
           </a:p>
           <a:p>
@@ -9859,7 +9859,7 @@
                 </a:solidFill>
                 <a:latin typeface="Arial"/>
               </a:rPr>
-              <a:t>Comprueba contrato activo en servicios_cliente 1.csv</a:t>
+              <a:t>Comprueba contrato activo en usuarios_servicios.csv</a:t>
             </a:r>
           </a:p>
         </p:txBody>
@@ -10809,7 +10809,7 @@
                 </a:solidFill>
                 <a:latin typeface="Arial"/>
               </a:rPr>
-              <a:t>servicios_cliente 1.csv: relaciona cada DNI con sus paquetes SVA contratados (NETFLIX, HBO, PRIME). Permite validar antes de escalar.</a:t>
+              <a:t>usuarios_servicios.csv (10.000 registros): relaciona cada DNI con sus paquetes SVA contratados (NETFLIX, HBO, PRIME). Permite validar antes de escalar.</a:t>
             </a:r>
           </a:p>
         </p:txBody>

</xml_diff>